<commit_message>
AJUSTAR IDIOMA ESQUELETO PROPOSTA
</commit_message>
<xml_diff>
--- a/Comercial/Modelos/MODELO-PADRAO.pptx
+++ b/Comercial/Modelos/MODELO-PADRAO.pptx
@@ -371,7 +371,7 @@
       </p:grpSpPr>
       <p:pic>
         <p:nvPicPr>
-          <p:cNvPr id="6" name="Imagem 5">
+          <p:cNvPr id="6" name="Imagem 5" descr="Gráfico de barras comparando vendas mensais de três produtos diferentes, com barras coloridas em azul, vermelho e verde representando cada produto. Eixo vertical mostra valores de vendas e eixo horizontal meses do ano, destacando pico de vendas em junho para produto azul.&#10;&#10;O conteúdo gerado por IA pode estar incorreto.">
             <a:extLst>
               <a:ext uri="{FF2B5EF4-FFF2-40B4-BE49-F238E27FC236}">
                 <a16:creationId xmlns:a16="http://schemas.microsoft.com/office/drawing/2014/main" id="{5F734387-32C3-6C5C-CA35-815A131BF2CB}"/>
@@ -407,10 +407,10 @@
       </p:pic>
       <p:sp>
         <p:nvSpPr>
-          <p:cNvPr id="7" name="Espaço Reservado para Texto 7">
+          <p:cNvPr id="3" name="Título 2">
             <a:extLst>
               <a:ext uri="{FF2B5EF4-FFF2-40B4-BE49-F238E27FC236}">
-                <a16:creationId xmlns:a16="http://schemas.microsoft.com/office/drawing/2014/main" id="{E0730EB7-16F5-7B71-0841-268F32B12B6B}"/>
+                <a16:creationId xmlns:a16="http://schemas.microsoft.com/office/drawing/2014/main" id="{98138D87-1629-8345-666F-042627976DCC}"/>
               </a:ext>
             </a:extLst>
           </p:cNvPr>
@@ -418,26 +418,24 @@
             <a:spLocks noGrp="1"/>
           </p:cNvSpPr>
           <p:nvPr>
-            <p:ph type="body" sz="quarter" idx="10" hasCustomPrompt="1"/>
+            <p:ph type="title"/>
           </p:nvPr>
         </p:nvSpPr>
         <p:spPr>
           <a:xfrm>
-            <a:off x="0" y="4421"/>
-            <a:ext cx="9150441" cy="339502"/>
+            <a:off x="0" y="16393"/>
+            <a:ext cx="9144000" cy="296857"/>
           </a:xfrm>
           <a:prstGeom prst="rect">
             <a:avLst/>
           </a:prstGeom>
         </p:spPr>
         <p:txBody>
-          <a:bodyPr anchor="ctr"/>
+          <a:bodyPr anchor="ctr" anchorCtr="1">
+            <a:normAutofit/>
+          </a:bodyPr>
           <a:lstStyle>
-            <a:lvl1pPr marL="0" indent="0" algn="ctr">
-              <a:buNone/>
-              <a:tabLst>
-                <a:tab pos="6276975" algn="l"/>
-              </a:tabLst>
+            <a:lvl1pPr algn="ctr">
               <a:defRPr sz="1600">
                 <a:solidFill>
                   <a:schemeClr val="bg1"/>
@@ -447,18 +445,11 @@
                 <a:cs typeface="Calibri" panose="020F0502020204030204" pitchFamily="34" charset="0"/>
               </a:defRPr>
             </a:lvl1pPr>
-            <a:lvl3pPr>
-              <a:tabLst>
-                <a:tab pos="7445375" algn="l"/>
-              </a:tabLst>
-              <a:defRPr/>
-            </a:lvl3pPr>
           </a:lstStyle>
           <a:p>
-            <a:pPr lvl="0"/>
             <a:r>
               <a:rPr lang="pt-BR" dirty="0"/>
-              <a:t>Clique para editar o texto mestre</a:t>
+              <a:t>Clique para editar o título Mestre</a:t>
             </a:r>
           </a:p>
         </p:txBody>

</xml_diff>